<commit_message>
slides and comments rebuilt, haven't fixed templates yet, haven't done finishing touches on slides
</commit_message>
<xml_diff>
--- a/slides/out/D2Final.pptx
+++ b/slides/out/D2Final.pptx
@@ -414,7 +414,7 @@
           <a:p>
             <a:fld id="{5BCAD085-E8A6-8845-BD4E-CB4CCA059FC4}" type="datetimeFigureOut">
               <a:rPr lang="en-US" smtClean="0"/>
-              <a:t>6/21/26</a:t>
+              <a:t>6/25/26</a:t>
             </a:fld>
             <a:endParaRPr lang="en-US"/>
           </a:p>
@@ -582,7 +582,7 @@
           <a:p>
             <a:fld id="{5BCAD085-E8A6-8845-BD4E-CB4CCA059FC4}" type="datetimeFigureOut">
               <a:rPr lang="en-US" smtClean="0"/>
-              <a:t>6/21/26</a:t>
+              <a:t>6/25/26</a:t>
             </a:fld>
             <a:endParaRPr lang="en-US"/>
           </a:p>
@@ -760,7 +760,7 @@
           <a:p>
             <a:fld id="{5BCAD085-E8A6-8845-BD4E-CB4CCA059FC4}" type="datetimeFigureOut">
               <a:rPr lang="en-US" smtClean="0"/>
-              <a:t>6/21/26</a:t>
+              <a:t>6/25/26</a:t>
             </a:fld>
             <a:endParaRPr lang="en-US"/>
           </a:p>
@@ -928,7 +928,7 @@
           <a:p>
             <a:fld id="{5BCAD085-E8A6-8845-BD4E-CB4CCA059FC4}" type="datetimeFigureOut">
               <a:rPr lang="en-US" smtClean="0"/>
-              <a:t>6/21/26</a:t>
+              <a:t>6/25/26</a:t>
             </a:fld>
             <a:endParaRPr lang="en-US"/>
           </a:p>
@@ -1173,7 +1173,7 @@
           <a:p>
             <a:fld id="{5BCAD085-E8A6-8845-BD4E-CB4CCA059FC4}" type="datetimeFigureOut">
               <a:rPr lang="en-US" smtClean="0"/>
-              <a:t>6/21/26</a:t>
+              <a:t>6/25/26</a:t>
             </a:fld>
             <a:endParaRPr lang="en-US"/>
           </a:p>
@@ -1458,7 +1458,7 @@
           <a:p>
             <a:fld id="{5BCAD085-E8A6-8845-BD4E-CB4CCA059FC4}" type="datetimeFigureOut">
               <a:rPr lang="en-US" smtClean="0"/>
-              <a:t>6/21/26</a:t>
+              <a:t>6/25/26</a:t>
             </a:fld>
             <a:endParaRPr lang="en-US"/>
           </a:p>
@@ -1877,7 +1877,7 @@
           <a:p>
             <a:fld id="{5BCAD085-E8A6-8845-BD4E-CB4CCA059FC4}" type="datetimeFigureOut">
               <a:rPr lang="en-US" smtClean="0"/>
-              <a:t>6/21/26</a:t>
+              <a:t>6/25/26</a:t>
             </a:fld>
             <a:endParaRPr lang="en-US"/>
           </a:p>
@@ -1994,7 +1994,7 @@
           <a:p>
             <a:fld id="{5BCAD085-E8A6-8845-BD4E-CB4CCA059FC4}" type="datetimeFigureOut">
               <a:rPr lang="en-US" smtClean="0"/>
-              <a:t>6/21/26</a:t>
+              <a:t>6/25/26</a:t>
             </a:fld>
             <a:endParaRPr lang="en-US"/>
           </a:p>
@@ -2089,7 +2089,7 @@
           <a:p>
             <a:fld id="{5BCAD085-E8A6-8845-BD4E-CB4CCA059FC4}" type="datetimeFigureOut">
               <a:rPr lang="en-US" smtClean="0"/>
-              <a:t>6/21/26</a:t>
+              <a:t>6/25/26</a:t>
             </a:fld>
             <a:endParaRPr lang="en-US"/>
           </a:p>
@@ -2364,7 +2364,7 @@
           <a:p>
             <a:fld id="{5BCAD085-E8A6-8845-BD4E-CB4CCA059FC4}" type="datetimeFigureOut">
               <a:rPr lang="en-US" smtClean="0"/>
-              <a:t>6/21/26</a:t>
+              <a:t>6/25/26</a:t>
             </a:fld>
             <a:endParaRPr lang="en-US"/>
           </a:p>
@@ -2616,7 +2616,7 @@
           <a:p>
             <a:fld id="{5BCAD085-E8A6-8845-BD4E-CB4CCA059FC4}" type="datetimeFigureOut">
               <a:rPr lang="en-US" smtClean="0"/>
-              <a:t>6/21/26</a:t>
+              <a:t>6/25/26</a:t>
             </a:fld>
             <a:endParaRPr lang="en-US"/>
           </a:p>
@@ -2827,7 +2827,7 @@
           <a:p>
             <a:fld id="{5BCAD085-E8A6-8845-BD4E-CB4CCA059FC4}" type="datetimeFigureOut">
               <a:rPr lang="en-US" smtClean="0"/>
-              <a:t>6/21/26</a:t>
+              <a:t>6/25/26</a:t>
             </a:fld>
             <a:endParaRPr lang="en-US"/>
           </a:p>
@@ -36491,7 +36491,7 @@
         <p:spPr>
           <a:xfrm>
             <a:off x="457200" y="1051560"/>
-            <a:ext cx="11277295" cy="731520"/>
+            <a:ext cx="11277295" cy="646331"/>
           </a:xfrm>
           <a:prstGeom prst="rect">
             <a:avLst/>
@@ -36506,14 +36506,47 @@
           <a:p>
             <a:pPr algn="l"/>
             <a:r>
+              <a:rPr sz="3600" b="1" i="0" dirty="0" err="1">
+                <a:solidFill>
+                  <a:srgbClr val="1A1A1A"/>
+                </a:solidFill>
+                <a:latin typeface="Poppins"/>
+              </a:rPr>
+              <a:t>GDScript</a:t>
+            </a:r>
+            <a:r>
+              <a:rPr sz="3600" b="1" i="0" dirty="0">
+                <a:solidFill>
+                  <a:srgbClr val="1A1A1A"/>
+                </a:solidFill>
+                <a:latin typeface="Poppins"/>
+              </a:rPr>
+              <a:t> is </a:t>
+            </a:r>
+            <a:r>
+              <a:rPr lang="en-US" sz="3600" b="1" i="0">
+                <a:solidFill>
+                  <a:srgbClr val="1A1A1A"/>
+                </a:solidFill>
+                <a:latin typeface="Poppins"/>
+              </a:rPr>
+              <a:t>just like </a:t>
+            </a:r>
+            <a:r>
               <a:rPr sz="3600" b="1" i="0">
                 <a:solidFill>
                   <a:srgbClr val="1A1A1A"/>
                 </a:solidFill>
                 <a:latin typeface="Poppins"/>
               </a:rPr>
-              <a:t>GDScript is Python — one word changes</a:t>
-            </a:r>
+              <a:t>Python </a:t>
+            </a:r>
+            <a:endParaRPr sz="3600" b="1" i="0" dirty="0">
+              <a:solidFill>
+                <a:srgbClr val="1A1A1A"/>
+              </a:solidFill>
+              <a:latin typeface="Poppins"/>
+            </a:endParaRPr>
           </a:p>
         </p:txBody>
       </p:sp>

</xml_diff>